<commit_message>
Add possible cause column to data quality issues log
Co-Authored-By: Claude Opus 5.5 <noreply@anthropic.com>
Claude-Session: https://claude.ai/code/session_01WXUNfjiAwmbN7LvNeo7xMt
</commit_message>
<xml_diff>
--- a/data-architecture/Data_Quality_Issues_Log.pptx
+++ b/data-architecture/Data_Quality_Issues_Log.pptx
@@ -508,6 +508,7 @@
 3. UnitE sends data out automatically but gets it back by hand, and nothing says which system wins.
 4. Commercial students and apprentices may be missing from college totals, because Dante, Onefile, JTL and Dataserve are not connected to UnitE or the SQL connector.
 The medium-priority issues are about feeds that bypass the connector, partial bursary data, the lack of status history, and student systems we have not yet mapped.
+Possible causes (in italics) are my reading of the map and meeting notes; confirm them with each system owner. Most come back to two root causes: systems were bought team by team without automated links, and nobody owns the master copy of each data item.
 The single most useful next step is to agree one system of record for each key data item, as part of Lesley and Kevin's single source work.</a:t>
             </a:r>
             <a:endParaRPr lang="en-US" dirty="0"/>
@@ -976,12 +977,13 @@
             <a:tbl>
               <a:tblPr/>
               <a:tblGrid>
-                <a:gridCol w="347472"/>
+                <a:gridCol w="301752"/>
+                <a:gridCol w="1463040"/>
+                <a:gridCol w="2606040"/>
+                <a:gridCol w="2423160"/>
+                <a:gridCol w="2057400"/>
                 <a:gridCol w="1920240"/>
-                <a:gridCol w="3429000"/>
-                <a:gridCol w="2606040"/>
-                <a:gridCol w="2331720"/>
-                <a:gridCol w="822960"/>
+                <a:gridCol w="685800"/>
               </a:tblGrid>
               <a:tr h="310896">
                 <a:tc>
@@ -1205,6 +1207,74 @@
                           <a:ea typeface="Calibri" pitchFamily="34" charset="-122"/>
                           <a:cs typeface="Calibri" pitchFamily="34" charset="-120"/>
                         </a:rPr>
+                        <a:t>Possible cause</a:t>
+                      </a:r>
+                      <a:endParaRPr lang="en-US" sz="1050" dirty="0">
+                        <a:latin typeface="Calibri" charset="0"/>
+                        <a:ea typeface="Calibri" charset="0"/>
+                        <a:cs typeface="Calibri" charset="0"/>
+                      </a:endParaRPr>
+                    </a:p>
+                  </a:txBody>
+                  <a:tcPr marL="54864" marR="54864" marT="27432" marB="27432" anchor="ctr">
+                    <a:lnL w="6350" cap="flat" cmpd="sng" algn="ctr">
+                      <a:solidFill>
+                        <a:srgbClr val="D9D4E3"/>
+                      </a:solidFill>
+                      <a:prstDash val="solid"/>
+                      <a:round/>
+                      <a:headEnd type="none" w="med" len="med"/>
+                      <a:tailEnd type="none" w="med" len="med"/>
+                    </a:lnL>
+                    <a:lnR w="6350" cap="flat" cmpd="sng" algn="ctr">
+                      <a:solidFill>
+                        <a:srgbClr val="D9D4E3"/>
+                      </a:solidFill>
+                      <a:prstDash val="solid"/>
+                      <a:round/>
+                      <a:headEnd type="none" w="med" len="med"/>
+                      <a:tailEnd type="none" w="med" len="med"/>
+                    </a:lnR>
+                    <a:lnT w="6350" cap="flat" cmpd="sng" algn="ctr">
+                      <a:solidFill>
+                        <a:srgbClr val="D9D4E3"/>
+                      </a:solidFill>
+                      <a:prstDash val="solid"/>
+                      <a:round/>
+                      <a:headEnd type="none" w="med" len="med"/>
+                      <a:tailEnd type="none" w="med" len="med"/>
+                    </a:lnT>
+                    <a:lnB w="6350" cap="flat" cmpd="sng" algn="ctr">
+                      <a:solidFill>
+                        <a:srgbClr val="D9D4E3"/>
+                      </a:solidFill>
+                      <a:prstDash val="solid"/>
+                      <a:round/>
+                      <a:headEnd type="none" w="med" len="med"/>
+                      <a:tailEnd type="none" w="med" len="med"/>
+                    </a:lnB>
+                    <a:solidFill>
+                      <a:srgbClr val="2B2350"/>
+                    </a:solidFill>
+                  </a:tcPr>
+                </a:tc>
+                <a:tc>
+                  <a:txBody>
+                    <a:bodyPr/>
+                    <a:lstStyle/>
+                    <a:p>
+                      <a:pPr indent="0" marL="0">
+                        <a:buNone/>
+                      </a:pPr>
+                      <a:r>
+                        <a:rPr lang="en-US" sz="1050" b="1" dirty="0">
+                          <a:solidFill>
+                            <a:srgbClr val="FFFFFF"/>
+                          </a:solidFill>
+                          <a:latin typeface="Calibri" pitchFamily="34" charset="0"/>
+                          <a:ea typeface="Calibri" pitchFamily="34" charset="-122"/>
+                          <a:cs typeface="Calibri" pitchFamily="34" charset="-120"/>
+                        </a:rPr>
                         <a:t>Effect on BI</a:t>
                       </a:r>
                       <a:endParaRPr lang="en-US" sz="1050" dirty="0">
@@ -1403,7 +1473,7 @@
                         <a:buNone/>
                       </a:pPr>
                       <a:r>
-                        <a:rPr lang="en-US" sz="950" b="1" dirty="0">
+                        <a:rPr lang="en-US" sz="900" b="1" dirty="0">
                           <a:solidFill>
                             <a:srgbClr val="A3206E"/>
                           </a:solidFill>
@@ -1413,7 +1483,7 @@
                         </a:rPr>
                         <a:t>1</a:t>
                       </a:r>
-                      <a:endParaRPr lang="en-US" sz="950" dirty="0">
+                      <a:endParaRPr lang="en-US" sz="900" dirty="0">
                         <a:latin typeface="Calibri" charset="0"/>
                         <a:ea typeface="Calibri" charset="0"/>
                         <a:cs typeface="Calibri" charset="0"/>
@@ -1471,7 +1541,7 @@
                         <a:buNone/>
                       </a:pPr>
                       <a:r>
-                        <a:rPr lang="en-US" sz="950" b="1" dirty="0">
+                        <a:rPr lang="en-US" sz="900" b="1" dirty="0">
                           <a:solidFill>
                             <a:srgbClr val="2B2350"/>
                           </a:solidFill>
@@ -1481,7 +1551,7 @@
                         </a:rPr>
                         <a:t>Same data keyed into several systems</a:t>
                       </a:r>
-                      <a:endParaRPr lang="en-US" sz="950" dirty="0">
+                      <a:endParaRPr lang="en-US" sz="900" dirty="0">
                         <a:latin typeface="Calibri" charset="0"/>
                         <a:ea typeface="Calibri" charset="0"/>
                         <a:cs typeface="Calibri" charset="0"/>
@@ -1539,7 +1609,7 @@
                         <a:buNone/>
                       </a:pPr>
                       <a:r>
-                        <a:rPr lang="en-US" sz="950" dirty="0">
+                        <a:rPr lang="en-US" sz="900" dirty="0">
                           <a:solidFill>
                             <a:srgbClr val="1F2233"/>
                           </a:solidFill>
@@ -1549,7 +1619,7 @@
                         </a:rPr>
                         <a:t>ASN typed into Enquirer, FVC Portal and TripleS. Application status and interview detail typed into both Enquirer and UnitE</a:t>
                       </a:r>
-                      <a:endParaRPr lang="en-US" sz="950" dirty="0">
+                      <a:endParaRPr lang="en-US" sz="900" dirty="0">
                         <a:latin typeface="Calibri" charset="0"/>
                         <a:ea typeface="Calibri" charset="0"/>
                         <a:cs typeface="Calibri" charset="0"/>
@@ -1607,7 +1677,7 @@
                         <a:buNone/>
                       </a:pPr>
                       <a:r>
-                        <a:rPr lang="en-US" sz="950" dirty="0">
+                        <a:rPr lang="en-US" sz="900" i="1" dirty="0">
                           <a:solidFill>
                             <a:srgbClr val="1F2233"/>
                           </a:solidFill>
@@ -1615,9 +1685,9 @@
                           <a:ea typeface="Calibri" pitchFamily="34" charset="-122"/>
                           <a:cs typeface="Calibri" pitchFamily="34" charset="-120"/>
                         </a:rPr>
-                        <a:t>Two versions of one number reach Power BI. May explain the RA5 gap (37.9% vs 31.0% / 54.5%)</a:t>
-                      </a:r>
-                      <a:endParaRPr lang="en-US" sz="950" dirty="0">
+                        <a:t>Each team works in its own system (admissions, registry, support, schools) and no one owns the master copy of each item</a:t>
+                      </a:r>
+                      <a:endParaRPr lang="en-US" sz="900" dirty="0">
                         <a:latin typeface="Calibri" charset="0"/>
                         <a:ea typeface="Calibri" charset="0"/>
                         <a:cs typeface="Calibri" charset="0"/>
@@ -1675,7 +1745,7 @@
                         <a:buNone/>
                       </a:pPr>
                       <a:r>
-                        <a:rPr lang="en-US" sz="950" dirty="0">
+                        <a:rPr lang="en-US" sz="900" dirty="0">
                           <a:solidFill>
                             <a:srgbClr val="1F2233"/>
                           </a:solidFill>
@@ -1683,9 +1753,77 @@
                           <a:ea typeface="Calibri" pitchFamily="34" charset="-122"/>
                           <a:cs typeface="Calibri" pitchFamily="34" charset="-120"/>
                         </a:rPr>
+                        <a:t>Two versions of one number reach Power BI; may explain the RA5 gap (37.9% vs 31.0% / 54.5%)</a:t>
+                      </a:r>
+                      <a:endParaRPr lang="en-US" sz="900" dirty="0">
+                        <a:latin typeface="Calibri" charset="0"/>
+                        <a:ea typeface="Calibri" charset="0"/>
+                        <a:cs typeface="Calibri" charset="0"/>
+                      </a:endParaRPr>
+                    </a:p>
+                  </a:txBody>
+                  <a:tcPr marL="54864" marR="54864" marT="27432" marB="27432" anchor="ctr">
+                    <a:lnL w="6350" cap="flat" cmpd="sng" algn="ctr">
+                      <a:solidFill>
+                        <a:srgbClr val="D9D4E3"/>
+                      </a:solidFill>
+                      <a:prstDash val="solid"/>
+                      <a:round/>
+                      <a:headEnd type="none" w="med" len="med"/>
+                      <a:tailEnd type="none" w="med" len="med"/>
+                    </a:lnL>
+                    <a:lnR w="6350" cap="flat" cmpd="sng" algn="ctr">
+                      <a:solidFill>
+                        <a:srgbClr val="D9D4E3"/>
+                      </a:solidFill>
+                      <a:prstDash val="solid"/>
+                      <a:round/>
+                      <a:headEnd type="none" w="med" len="med"/>
+                      <a:tailEnd type="none" w="med" len="med"/>
+                    </a:lnR>
+                    <a:lnT w="6350" cap="flat" cmpd="sng" algn="ctr">
+                      <a:solidFill>
+                        <a:srgbClr val="D9D4E3"/>
+                      </a:solidFill>
+                      <a:prstDash val="solid"/>
+                      <a:round/>
+                      <a:headEnd type="none" w="med" len="med"/>
+                      <a:tailEnd type="none" w="med" len="med"/>
+                    </a:lnT>
+                    <a:lnB w="6350" cap="flat" cmpd="sng" algn="ctr">
+                      <a:solidFill>
+                        <a:srgbClr val="D9D4E3"/>
+                      </a:solidFill>
+                      <a:prstDash val="solid"/>
+                      <a:round/>
+                      <a:headEnd type="none" w="med" len="med"/>
+                      <a:tailEnd type="none" w="med" len="med"/>
+                    </a:lnB>
+                    <a:solidFill>
+                      <a:srgbClr val="FFFFFF"/>
+                    </a:solidFill>
+                  </a:tcPr>
+                </a:tc>
+                <a:tc>
+                  <a:txBody>
+                    <a:bodyPr/>
+                    <a:lstStyle/>
+                    <a:p>
+                      <a:pPr indent="0" marL="0">
+                        <a:buNone/>
+                      </a:pPr>
+                      <a:r>
+                        <a:rPr lang="en-US" sz="900" dirty="0">
+                          <a:solidFill>
+                            <a:srgbClr val="1F2233"/>
+                          </a:solidFill>
+                          <a:latin typeface="Calibri" pitchFamily="34" charset="0"/>
+                          <a:ea typeface="Calibri" pitchFamily="34" charset="-122"/>
+                          <a:cs typeface="Calibri" pitchFamily="34" charset="-120"/>
+                        </a:rPr>
                         <a:t>Agree one system of record per data item (Lesley, Kevin)</a:t>
                       </a:r>
-                      <a:endParaRPr lang="en-US" sz="950" dirty="0">
+                      <a:endParaRPr lang="en-US" sz="900" dirty="0">
                         <a:latin typeface="Calibri" charset="0"/>
                         <a:ea typeface="Calibri" charset="0"/>
                         <a:cs typeface="Calibri" charset="0"/>
@@ -1743,7 +1881,7 @@
                         <a:buNone/>
                       </a:pPr>
                       <a:r>
-                        <a:rPr lang="en-US" sz="950" b="1" dirty="0">
+                        <a:rPr lang="en-US" sz="900" b="1" dirty="0">
                           <a:solidFill>
                             <a:srgbClr val="8C1A5C"/>
                           </a:solidFill>
@@ -1753,7 +1891,7 @@
                         </a:rPr>
                         <a:t>High</a:t>
                       </a:r>
-                      <a:endParaRPr lang="en-US" sz="950" dirty="0">
+                      <a:endParaRPr lang="en-US" sz="900" dirty="0">
                         <a:latin typeface="Calibri" charset="0"/>
                         <a:ea typeface="Calibri" charset="0"/>
                         <a:cs typeface="Calibri" charset="0"/>
@@ -1813,7 +1951,7 @@
                         <a:buNone/>
                       </a:pPr>
                       <a:r>
-                        <a:rPr lang="en-US" sz="950" b="1" dirty="0">
+                        <a:rPr lang="en-US" sz="900" b="1" dirty="0">
                           <a:solidFill>
                             <a:srgbClr val="A3206E"/>
                           </a:solidFill>
@@ -1823,7 +1961,7 @@
                         </a:rPr>
                         <a:t>2</a:t>
                       </a:r>
-                      <a:endParaRPr lang="en-US" sz="950" dirty="0">
+                      <a:endParaRPr lang="en-US" sz="900" dirty="0">
                         <a:latin typeface="Calibri" charset="0"/>
                         <a:ea typeface="Calibri" charset="0"/>
                         <a:cs typeface="Calibri" charset="0"/>
@@ -1881,7 +2019,7 @@
                         <a:buNone/>
                       </a:pPr>
                       <a:r>
-                        <a:rPr lang="en-US" sz="950" b="1" dirty="0">
+                        <a:rPr lang="en-US" sz="900" b="1" dirty="0">
                           <a:solidFill>
                             <a:srgbClr val="2B2350"/>
                           </a:solidFill>
@@ -1891,7 +2029,7 @@
                         </a:rPr>
                         <a:t>Manual steps on the recruitment path</a:t>
                       </a:r>
-                      <a:endParaRPr lang="en-US" sz="950" dirty="0">
+                      <a:endParaRPr lang="en-US" sz="900" dirty="0">
                         <a:latin typeface="Calibri" charset="0"/>
                         <a:ea typeface="Calibri" charset="0"/>
                         <a:cs typeface="Calibri" charset="0"/>
@@ -1949,7 +2087,7 @@
                         <a:buNone/>
                       </a:pPr>
                       <a:r>
-                        <a:rPr lang="en-US" sz="950" dirty="0">
+                        <a:rPr lang="en-US" sz="900" dirty="0">
                           <a:solidFill>
                             <a:srgbClr val="1F2233"/>
                           </a:solidFill>
@@ -1959,7 +2097,7 @@
                         </a:rPr>
                         <a:t>7 manual hand-offs, including Enquirer → UnitE, plus 6 manual input points</a:t>
                       </a:r>
-                      <a:endParaRPr lang="en-US" sz="950" dirty="0">
+                      <a:endParaRPr lang="en-US" sz="900" dirty="0">
                         <a:latin typeface="Calibri" charset="0"/>
                         <a:ea typeface="Calibri" charset="0"/>
                         <a:cs typeface="Calibri" charset="0"/>
@@ -2017,7 +2155,7 @@
                         <a:buNone/>
                       </a:pPr>
                       <a:r>
-                        <a:rPr lang="en-US" sz="950" dirty="0">
+                        <a:rPr lang="en-US" sz="900" i="1" dirty="0">
                           <a:solidFill>
                             <a:srgbClr val="1F2233"/>
                           </a:solidFill>
@@ -2025,9 +2163,77 @@
                           <a:ea typeface="Calibri" pitchFamily="34" charset="-122"/>
                           <a:cs typeface="Calibri" pitchFamily="34" charset="-120"/>
                         </a:rPr>
+                        <a:t>No automated link was built between the systems, so re-keying became the routine workaround</a:t>
+                      </a:r>
+                      <a:endParaRPr lang="en-US" sz="900" dirty="0">
+                        <a:latin typeface="Calibri" charset="0"/>
+                        <a:ea typeface="Calibri" charset="0"/>
+                        <a:cs typeface="Calibri" charset="0"/>
+                      </a:endParaRPr>
+                    </a:p>
+                  </a:txBody>
+                  <a:tcPr marL="54864" marR="54864" marT="27432" marB="27432" anchor="ctr">
+                    <a:lnL w="6350" cap="flat" cmpd="sng" algn="ctr">
+                      <a:solidFill>
+                        <a:srgbClr val="D9D4E3"/>
+                      </a:solidFill>
+                      <a:prstDash val="solid"/>
+                      <a:round/>
+                      <a:headEnd type="none" w="med" len="med"/>
+                      <a:tailEnd type="none" w="med" len="med"/>
+                    </a:lnL>
+                    <a:lnR w="6350" cap="flat" cmpd="sng" algn="ctr">
+                      <a:solidFill>
+                        <a:srgbClr val="D9D4E3"/>
+                      </a:solidFill>
+                      <a:prstDash val="solid"/>
+                      <a:round/>
+                      <a:headEnd type="none" w="med" len="med"/>
+                      <a:tailEnd type="none" w="med" len="med"/>
+                    </a:lnR>
+                    <a:lnT w="6350" cap="flat" cmpd="sng" algn="ctr">
+                      <a:solidFill>
+                        <a:srgbClr val="D9D4E3"/>
+                      </a:solidFill>
+                      <a:prstDash val="solid"/>
+                      <a:round/>
+                      <a:headEnd type="none" w="med" len="med"/>
+                      <a:tailEnd type="none" w="med" len="med"/>
+                    </a:lnT>
+                    <a:lnB w="6350" cap="flat" cmpd="sng" algn="ctr">
+                      <a:solidFill>
+                        <a:srgbClr val="D9D4E3"/>
+                      </a:solidFill>
+                      <a:prstDash val="solid"/>
+                      <a:round/>
+                      <a:headEnd type="none" w="med" len="med"/>
+                      <a:tailEnd type="none" w="med" len="med"/>
+                    </a:lnB>
+                    <a:solidFill>
+                      <a:srgbClr val="F7F5FA"/>
+                    </a:solidFill>
+                  </a:tcPr>
+                </a:tc>
+                <a:tc>
+                  <a:txBody>
+                    <a:bodyPr/>
+                    <a:lstStyle/>
+                    <a:p>
+                      <a:pPr indent="0" marL="0">
+                        <a:buNone/>
+                      </a:pPr>
+                      <a:r>
+                        <a:rPr lang="en-US" sz="900" dirty="0">
+                          <a:solidFill>
+                            <a:srgbClr val="1F2233"/>
+                          </a:solidFill>
+                          <a:latin typeface="Calibri" pitchFamily="34" charset="0"/>
+                          <a:ea typeface="Calibri" pitchFamily="34" charset="-122"/>
+                          <a:cs typeface="Calibri" pitchFamily="34" charset="-120"/>
+                        </a:rPr>
                         <a:t>Delays, typing errors and missing records between applications and enrolments</a:t>
                       </a:r>
-                      <a:endParaRPr lang="en-US" sz="950" dirty="0">
+                      <a:endParaRPr lang="en-US" sz="900" dirty="0">
                         <a:latin typeface="Calibri" charset="0"/>
                         <a:ea typeface="Calibri" charset="0"/>
                         <a:cs typeface="Calibri" charset="0"/>
@@ -2085,7 +2291,7 @@
                         <a:buNone/>
                       </a:pPr>
                       <a:r>
-                        <a:rPr lang="en-US" sz="950" dirty="0">
+                        <a:rPr lang="en-US" sz="900" dirty="0">
                           <a:solidFill>
                             <a:srgbClr val="1F2233"/>
                           </a:solidFill>
@@ -2095,7 +2301,7 @@
                         </a:rPr>
                         <a:t>Monthly count check: Enquirer vs UnitE vs RA5, starting with YCCJ/AL</a:t>
                       </a:r>
-                      <a:endParaRPr lang="en-US" sz="950" dirty="0">
+                      <a:endParaRPr lang="en-US" sz="900" dirty="0">
                         <a:latin typeface="Calibri" charset="0"/>
                         <a:ea typeface="Calibri" charset="0"/>
                         <a:cs typeface="Calibri" charset="0"/>
@@ -2153,7 +2359,7 @@
                         <a:buNone/>
                       </a:pPr>
                       <a:r>
-                        <a:rPr lang="en-US" sz="950" b="1" dirty="0">
+                        <a:rPr lang="en-US" sz="900" b="1" dirty="0">
                           <a:solidFill>
                             <a:srgbClr val="8C1A5C"/>
                           </a:solidFill>
@@ -2163,7 +2369,7 @@
                         </a:rPr>
                         <a:t>High</a:t>
                       </a:r>
-                      <a:endParaRPr lang="en-US" sz="950" dirty="0">
+                      <a:endParaRPr lang="en-US" sz="900" dirty="0">
                         <a:latin typeface="Calibri" charset="0"/>
                         <a:ea typeface="Calibri" charset="0"/>
                         <a:cs typeface="Calibri" charset="0"/>
@@ -2223,7 +2429,7 @@
                         <a:buNone/>
                       </a:pPr>
                       <a:r>
-                        <a:rPr lang="en-US" sz="950" b="1" dirty="0">
+                        <a:rPr lang="en-US" sz="900" b="1" dirty="0">
                           <a:solidFill>
                             <a:srgbClr val="A3206E"/>
                           </a:solidFill>
@@ -2233,7 +2439,7 @@
                         </a:rPr>
                         <a:t>3</a:t>
                       </a:r>
-                      <a:endParaRPr lang="en-US" sz="950" dirty="0">
+                      <a:endParaRPr lang="en-US" sz="900" dirty="0">
                         <a:latin typeface="Calibri" charset="0"/>
                         <a:ea typeface="Calibri" charset="0"/>
                         <a:cs typeface="Calibri" charset="0"/>
@@ -2291,7 +2497,7 @@
                         <a:buNone/>
                       </a:pPr>
                       <a:r>
-                        <a:rPr lang="en-US" sz="950" b="1" dirty="0">
+                        <a:rPr lang="en-US" sz="900" b="1" dirty="0">
                           <a:solidFill>
                             <a:srgbClr val="2B2350"/>
                           </a:solidFill>
@@ -2301,7 +2507,7 @@
                         </a:rPr>
                         <a:t>Two-way loops around UnitE</a:t>
                       </a:r>
-                      <a:endParaRPr lang="en-US" sz="950" dirty="0">
+                      <a:endParaRPr lang="en-US" sz="900" dirty="0">
                         <a:latin typeface="Calibri" charset="0"/>
                         <a:ea typeface="Calibri" charset="0"/>
                         <a:cs typeface="Calibri" charset="0"/>
@@ -2359,7 +2565,7 @@
                         <a:buNone/>
                       </a:pPr>
                       <a:r>
-                        <a:rPr lang="en-US" sz="950" dirty="0">
+                        <a:rPr lang="en-US" sz="900" dirty="0">
                           <a:solidFill>
                             <a:srgbClr val="1F2233"/>
                           </a:solidFill>
@@ -2369,7 +2575,7 @@
                         </a:rPr>
                         <a:t>UnitE sends data out automatically; Enquirer, Bursary, Student Portal and FVC Portal send it back by hand</a:t>
                       </a:r>
-                      <a:endParaRPr lang="en-US" sz="950" dirty="0">
+                      <a:endParaRPr lang="en-US" sz="900" dirty="0">
                         <a:latin typeface="Calibri" charset="0"/>
                         <a:ea typeface="Calibri" charset="0"/>
                         <a:cs typeface="Calibri" charset="0"/>
@@ -2427,7 +2633,7 @@
                         <a:buNone/>
                       </a:pPr>
                       <a:r>
-                        <a:rPr lang="en-US" sz="950" dirty="0">
+                        <a:rPr lang="en-US" sz="900" i="1" dirty="0">
                           <a:solidFill>
                             <a:srgbClr val="1F2233"/>
                           </a:solidFill>
@@ -2435,9 +2641,9 @@
                           <a:ea typeface="Calibri" pitchFamily="34" charset="-122"/>
                           <a:cs typeface="Calibri" pitchFamily="34" charset="-120"/>
                         </a:rPr>
-                        <a:t>No rule for which system wins. Power BI reads both UnitE and Enquirer</a:t>
-                      </a:r>
-                      <a:endParaRPr lang="en-US" sz="950" dirty="0">
+                        <a:t>Other systems need to correct or add data but have no write-back link to UnitE</a:t>
+                      </a:r>
+                      <a:endParaRPr lang="en-US" sz="900" dirty="0">
                         <a:latin typeface="Calibri" charset="0"/>
                         <a:ea typeface="Calibri" charset="0"/>
                         <a:cs typeface="Calibri" charset="0"/>
@@ -2495,7 +2701,7 @@
                         <a:buNone/>
                       </a:pPr>
                       <a:r>
-                        <a:rPr lang="en-US" sz="950" dirty="0">
+                        <a:rPr lang="en-US" sz="900" dirty="0">
                           <a:solidFill>
                             <a:srgbClr val="1F2233"/>
                           </a:solidFill>
@@ -2503,9 +2709,77 @@
                           <a:ea typeface="Calibri" pitchFamily="34" charset="-122"/>
                           <a:cs typeface="Calibri" pitchFamily="34" charset="-120"/>
                         </a:rPr>
+                        <a:t>No rule for which system wins; Power BI reads both UnitE and Enquirer</a:t>
+                      </a:r>
+                      <a:endParaRPr lang="en-US" sz="900" dirty="0">
+                        <a:latin typeface="Calibri" charset="0"/>
+                        <a:ea typeface="Calibri" charset="0"/>
+                        <a:cs typeface="Calibri" charset="0"/>
+                      </a:endParaRPr>
+                    </a:p>
+                  </a:txBody>
+                  <a:tcPr marL="54864" marR="54864" marT="27432" marB="27432" anchor="ctr">
+                    <a:lnL w="6350" cap="flat" cmpd="sng" algn="ctr">
+                      <a:solidFill>
+                        <a:srgbClr val="D9D4E3"/>
+                      </a:solidFill>
+                      <a:prstDash val="solid"/>
+                      <a:round/>
+                      <a:headEnd type="none" w="med" len="med"/>
+                      <a:tailEnd type="none" w="med" len="med"/>
+                    </a:lnL>
+                    <a:lnR w="6350" cap="flat" cmpd="sng" algn="ctr">
+                      <a:solidFill>
+                        <a:srgbClr val="D9D4E3"/>
+                      </a:solidFill>
+                      <a:prstDash val="solid"/>
+                      <a:round/>
+                      <a:headEnd type="none" w="med" len="med"/>
+                      <a:tailEnd type="none" w="med" len="med"/>
+                    </a:lnR>
+                    <a:lnT w="6350" cap="flat" cmpd="sng" algn="ctr">
+                      <a:solidFill>
+                        <a:srgbClr val="D9D4E3"/>
+                      </a:solidFill>
+                      <a:prstDash val="solid"/>
+                      <a:round/>
+                      <a:headEnd type="none" w="med" len="med"/>
+                      <a:tailEnd type="none" w="med" len="med"/>
+                    </a:lnT>
+                    <a:lnB w="6350" cap="flat" cmpd="sng" algn="ctr">
+                      <a:solidFill>
+                        <a:srgbClr val="D9D4E3"/>
+                      </a:solidFill>
+                      <a:prstDash val="solid"/>
+                      <a:round/>
+                      <a:headEnd type="none" w="med" len="med"/>
+                      <a:tailEnd type="none" w="med" len="med"/>
+                    </a:lnB>
+                    <a:solidFill>
+                      <a:srgbClr val="FFFFFF"/>
+                    </a:solidFill>
+                  </a:tcPr>
+                </a:tc>
+                <a:tc>
+                  <a:txBody>
+                    <a:bodyPr/>
+                    <a:lstStyle/>
+                    <a:p>
+                      <a:pPr indent="0" marL="0">
+                        <a:buNone/>
+                      </a:pPr>
+                      <a:r>
+                        <a:rPr lang="en-US" sz="900" dirty="0">
+                          <a:solidFill>
+                            <a:srgbClr val="1F2233"/>
+                          </a:solidFill>
+                          <a:latin typeface="Calibri" pitchFamily="34" charset="0"/>
+                          <a:ea typeface="Calibri" pitchFamily="34" charset="-122"/>
+                          <a:cs typeface="Calibri" pitchFamily="34" charset="-120"/>
+                        </a:rPr>
                         <a:t>Covered by the system-of-record agreement (Lesley, Kevin)</a:t>
                       </a:r>
-                      <a:endParaRPr lang="en-US" sz="950" dirty="0">
+                      <a:endParaRPr lang="en-US" sz="900" dirty="0">
                         <a:latin typeface="Calibri" charset="0"/>
                         <a:ea typeface="Calibri" charset="0"/>
                         <a:cs typeface="Calibri" charset="0"/>
@@ -2563,7 +2837,7 @@
                         <a:buNone/>
                       </a:pPr>
                       <a:r>
-                        <a:rPr lang="en-US" sz="950" b="1" dirty="0">
+                        <a:rPr lang="en-US" sz="900" b="1" dirty="0">
                           <a:solidFill>
                             <a:srgbClr val="8C1A5C"/>
                           </a:solidFill>
@@ -2573,7 +2847,7 @@
                         </a:rPr>
                         <a:t>High</a:t>
                       </a:r>
-                      <a:endParaRPr lang="en-US" sz="950" dirty="0">
+                      <a:endParaRPr lang="en-US" sz="900" dirty="0">
                         <a:latin typeface="Calibri" charset="0"/>
                         <a:ea typeface="Calibri" charset="0"/>
                         <a:cs typeface="Calibri" charset="0"/>
@@ -2633,7 +2907,7 @@
                         <a:buNone/>
                       </a:pPr>
                       <a:r>
-                        <a:rPr lang="en-US" sz="950" b="1" dirty="0">
+                        <a:rPr lang="en-US" sz="900" b="1" dirty="0">
                           <a:solidFill>
                             <a:srgbClr val="A3206E"/>
                           </a:solidFill>
@@ -2643,7 +2917,7 @@
                         </a:rPr>
                         <a:t>4</a:t>
                       </a:r>
-                      <a:endParaRPr lang="en-US" sz="950" dirty="0">
+                      <a:endParaRPr lang="en-US" sz="900" dirty="0">
                         <a:latin typeface="Calibri" charset="0"/>
                         <a:ea typeface="Calibri" charset="0"/>
                         <a:cs typeface="Calibri" charset="0"/>
@@ -2701,7 +2975,7 @@
                         <a:buNone/>
                       </a:pPr>
                       <a:r>
-                        <a:rPr lang="en-US" sz="950" b="1" dirty="0">
+                        <a:rPr lang="en-US" sz="900" b="1" dirty="0">
                           <a:solidFill>
                             <a:srgbClr val="2B2350"/>
                           </a:solidFill>
@@ -2711,7 +2985,7 @@
                         </a:rPr>
                         <a:t>Students missing from UnitE or BI</a:t>
                       </a:r>
-                      <a:endParaRPr lang="en-US" sz="950" dirty="0">
+                      <a:endParaRPr lang="en-US" sz="900" dirty="0">
                         <a:latin typeface="Calibri" charset="0"/>
                         <a:ea typeface="Calibri" charset="0"/>
                         <a:cs typeface="Calibri" charset="0"/>
@@ -2769,7 +3043,7 @@
                         <a:buNone/>
                       </a:pPr>
                       <a:r>
-                        <a:rPr lang="en-US" sz="950" dirty="0">
+                        <a:rPr lang="en-US" sz="900" dirty="0">
                           <a:solidFill>
                             <a:srgbClr val="1F2233"/>
                           </a:solidFill>
@@ -2779,7 +3053,7 @@
                         </a:rPr>
                         <a:t>Dante "not on Unit-E" and not on the connector. Onefile, JTL and Dataserve unconnected. Celcat not on the connector</a:t>
                       </a:r>
-                      <a:endParaRPr lang="en-US" sz="950" dirty="0">
+                      <a:endParaRPr lang="en-US" sz="900" dirty="0">
                         <a:latin typeface="Calibri" charset="0"/>
                         <a:ea typeface="Calibri" charset="0"/>
                         <a:cs typeface="Calibri" charset="0"/>
@@ -2837,7 +3111,7 @@
                         <a:buNone/>
                       </a:pPr>
                       <a:r>
-                        <a:rPr lang="en-US" sz="950" dirty="0">
+                        <a:rPr lang="en-US" sz="900" i="1" dirty="0">
                           <a:solidFill>
                             <a:srgbClr val="1F2233"/>
                           </a:solidFill>
@@ -2845,9 +3119,77 @@
                           <a:ea typeface="Calibri" pitchFamily="34" charset="-122"/>
                           <a:cs typeface="Calibri" pitchFamily="34" charset="-120"/>
                         </a:rPr>
+                        <a:t>Commercial and apprenticeship courses run on separate systems with their own processes; BI was built around UnitE and Enquirer</a:t>
+                      </a:r>
+                      <a:endParaRPr lang="en-US" sz="900" dirty="0">
+                        <a:latin typeface="Calibri" charset="0"/>
+                        <a:ea typeface="Calibri" charset="0"/>
+                        <a:cs typeface="Calibri" charset="0"/>
+                      </a:endParaRPr>
+                    </a:p>
+                  </a:txBody>
+                  <a:tcPr marL="54864" marR="54864" marT="27432" marB="27432" anchor="ctr">
+                    <a:lnL w="6350" cap="flat" cmpd="sng" algn="ctr">
+                      <a:solidFill>
+                        <a:srgbClr val="D9D4E3"/>
+                      </a:solidFill>
+                      <a:prstDash val="solid"/>
+                      <a:round/>
+                      <a:headEnd type="none" w="med" len="med"/>
+                      <a:tailEnd type="none" w="med" len="med"/>
+                    </a:lnL>
+                    <a:lnR w="6350" cap="flat" cmpd="sng" algn="ctr">
+                      <a:solidFill>
+                        <a:srgbClr val="D9D4E3"/>
+                      </a:solidFill>
+                      <a:prstDash val="solid"/>
+                      <a:round/>
+                      <a:headEnd type="none" w="med" len="med"/>
+                      <a:tailEnd type="none" w="med" len="med"/>
+                    </a:lnR>
+                    <a:lnT w="6350" cap="flat" cmpd="sng" algn="ctr">
+                      <a:solidFill>
+                        <a:srgbClr val="D9D4E3"/>
+                      </a:solidFill>
+                      <a:prstDash val="solid"/>
+                      <a:round/>
+                      <a:headEnd type="none" w="med" len="med"/>
+                      <a:tailEnd type="none" w="med" len="med"/>
+                    </a:lnT>
+                    <a:lnB w="6350" cap="flat" cmpd="sng" algn="ctr">
+                      <a:solidFill>
+                        <a:srgbClr val="D9D4E3"/>
+                      </a:solidFill>
+                      <a:prstDash val="solid"/>
+                      <a:round/>
+                      <a:headEnd type="none" w="med" len="med"/>
+                      <a:tailEnd type="none" w="med" len="med"/>
+                    </a:lnB>
+                    <a:solidFill>
+                      <a:srgbClr val="F7F5FA"/>
+                    </a:solidFill>
+                  </a:tcPr>
+                </a:tc>
+                <a:tc>
+                  <a:txBody>
+                    <a:bodyPr/>
+                    <a:lstStyle/>
+                    <a:p>
+                      <a:pPr indent="0" marL="0">
+                        <a:buNone/>
+                      </a:pPr>
+                      <a:r>
+                        <a:rPr lang="en-US" sz="900" dirty="0">
+                          <a:solidFill>
+                            <a:srgbClr val="1F2233"/>
+                          </a:solidFill>
+                          <a:latin typeface="Calibri" pitchFamily="34" charset="0"/>
+                          <a:ea typeface="Calibri" pitchFamily="34" charset="-122"/>
+                          <a:cs typeface="Calibri" pitchFamily="34" charset="-120"/>
+                        </a:rPr>
                         <a:t>Totals may quietly leave out commercial students and apprentices</a:t>
                       </a:r>
-                      <a:endParaRPr lang="en-US" sz="950" dirty="0">
+                      <a:endParaRPr lang="en-US" sz="900" dirty="0">
                         <a:latin typeface="Calibri" charset="0"/>
                         <a:ea typeface="Calibri" charset="0"/>
                         <a:cs typeface="Calibri" charset="0"/>
@@ -2905,7 +3247,7 @@
                         <a:buNone/>
                       </a:pPr>
                       <a:r>
-                        <a:rPr lang="en-US" sz="950" dirty="0">
+                        <a:rPr lang="en-US" sz="900" dirty="0">
                           <a:solidFill>
                             <a:srgbClr val="1F2233"/>
                           </a:solidFill>
@@ -2915,7 +3257,7 @@
                         </a:rPr>
                         <a:t>Ask Kevin which systems can join the SQL connector</a:t>
                       </a:r>
-                      <a:endParaRPr lang="en-US" sz="950" dirty="0">
+                      <a:endParaRPr lang="en-US" sz="900" dirty="0">
                         <a:latin typeface="Calibri" charset="0"/>
                         <a:ea typeface="Calibri" charset="0"/>
                         <a:cs typeface="Calibri" charset="0"/>
@@ -2973,7 +3315,7 @@
                         <a:buNone/>
                       </a:pPr>
                       <a:r>
-                        <a:rPr lang="en-US" sz="950" b="1" dirty="0">
+                        <a:rPr lang="en-US" sz="900" b="1" dirty="0">
                           <a:solidFill>
                             <a:srgbClr val="8C1A5C"/>
                           </a:solidFill>
@@ -2983,7 +3325,7 @@
                         </a:rPr>
                         <a:t>High</a:t>
                       </a:r>
-                      <a:endParaRPr lang="en-US" sz="950" dirty="0">
+                      <a:endParaRPr lang="en-US" sz="900" dirty="0">
                         <a:latin typeface="Calibri" charset="0"/>
                         <a:ea typeface="Calibri" charset="0"/>
                         <a:cs typeface="Calibri" charset="0"/>
@@ -3043,7 +3385,7 @@
                         <a:buNone/>
                       </a:pPr>
                       <a:r>
-                        <a:rPr lang="en-US" sz="950" b="1" dirty="0">
+                        <a:rPr lang="en-US" sz="900" b="1" dirty="0">
                           <a:solidFill>
                             <a:srgbClr val="A3206E"/>
                           </a:solidFill>
@@ -3053,7 +3395,7 @@
                         </a:rPr>
                         <a:t>5</a:t>
                       </a:r>
-                      <a:endParaRPr lang="en-US" sz="950" dirty="0">
+                      <a:endParaRPr lang="en-US" sz="900" dirty="0">
                         <a:latin typeface="Calibri" charset="0"/>
                         <a:ea typeface="Calibri" charset="0"/>
                         <a:cs typeface="Calibri" charset="0"/>
@@ -3111,7 +3453,7 @@
                         <a:buNone/>
                       </a:pPr>
                       <a:r>
-                        <a:rPr lang="en-US" sz="950" b="1" dirty="0">
+                        <a:rPr lang="en-US" sz="900" b="1" dirty="0">
                           <a:solidFill>
                             <a:srgbClr val="2B2350"/>
                           </a:solidFill>
@@ -3121,7 +3463,7 @@
                         </a:rPr>
                         <a:t>Feeds that bypass the connector</a:t>
                       </a:r>
-                      <a:endParaRPr lang="en-US" sz="950" dirty="0">
+                      <a:endParaRPr lang="en-US" sz="900" dirty="0">
                         <a:latin typeface="Calibri" charset="0"/>
                         <a:ea typeface="Calibri" charset="0"/>
                         <a:cs typeface="Calibri" charset="0"/>
@@ -3179,7 +3521,7 @@
                         <a:buNone/>
                       </a:pPr>
                       <a:r>
-                        <a:rPr lang="en-US" sz="950" dirty="0">
+                        <a:rPr lang="en-US" sz="900" dirty="0">
                           <a:solidFill>
                             <a:srgbClr val="1F2233"/>
                           </a:solidFill>
@@ -3189,7 +3531,7 @@
                         </a:rPr>
                         <a:t>Complaints and UNIDESK feed Power BI directly; MS Access by hand. RA5's semantic model source unconfirmed</a:t>
                       </a:r>
-                      <a:endParaRPr lang="en-US" sz="950" dirty="0">
+                      <a:endParaRPr lang="en-US" sz="900" dirty="0">
                         <a:latin typeface="Calibri" charset="0"/>
                         <a:ea typeface="Calibri" charset="0"/>
                         <a:cs typeface="Calibri" charset="0"/>
@@ -3247,7 +3589,7 @@
                         <a:buNone/>
                       </a:pPr>
                       <a:r>
-                        <a:rPr lang="en-US" sz="950" dirty="0">
+                        <a:rPr lang="en-US" sz="900" i="1" dirty="0">
                           <a:solidFill>
                             <a:srgbClr val="1F2233"/>
                           </a:solidFill>
@@ -3255,9 +3597,77 @@
                           <a:ea typeface="Calibri" pitchFamily="34" charset="-122"/>
                           <a:cs typeface="Calibri" pitchFamily="34" charset="-120"/>
                         </a:rPr>
+                        <a:t>Teams built quick reports for their own needs; no shared rule on how data must reach Power BI</a:t>
+                      </a:r>
+                      <a:endParaRPr lang="en-US" sz="900" dirty="0">
+                        <a:latin typeface="Calibri" charset="0"/>
+                        <a:ea typeface="Calibri" charset="0"/>
+                        <a:cs typeface="Calibri" charset="0"/>
+                      </a:endParaRPr>
+                    </a:p>
+                  </a:txBody>
+                  <a:tcPr marL="54864" marR="54864" marT="27432" marB="27432" anchor="ctr">
+                    <a:lnL w="6350" cap="flat" cmpd="sng" algn="ctr">
+                      <a:solidFill>
+                        <a:srgbClr val="D9D4E3"/>
+                      </a:solidFill>
+                      <a:prstDash val="solid"/>
+                      <a:round/>
+                      <a:headEnd type="none" w="med" len="med"/>
+                      <a:tailEnd type="none" w="med" len="med"/>
+                    </a:lnL>
+                    <a:lnR w="6350" cap="flat" cmpd="sng" algn="ctr">
+                      <a:solidFill>
+                        <a:srgbClr val="D9D4E3"/>
+                      </a:solidFill>
+                      <a:prstDash val="solid"/>
+                      <a:round/>
+                      <a:headEnd type="none" w="med" len="med"/>
+                      <a:tailEnd type="none" w="med" len="med"/>
+                    </a:lnR>
+                    <a:lnT w="6350" cap="flat" cmpd="sng" algn="ctr">
+                      <a:solidFill>
+                        <a:srgbClr val="D9D4E3"/>
+                      </a:solidFill>
+                      <a:prstDash val="solid"/>
+                      <a:round/>
+                      <a:headEnd type="none" w="med" len="med"/>
+                      <a:tailEnd type="none" w="med" len="med"/>
+                    </a:lnT>
+                    <a:lnB w="6350" cap="flat" cmpd="sng" algn="ctr">
+                      <a:solidFill>
+                        <a:srgbClr val="D9D4E3"/>
+                      </a:solidFill>
+                      <a:prstDash val="solid"/>
+                      <a:round/>
+                      <a:headEnd type="none" w="med" len="med"/>
+                      <a:tailEnd type="none" w="med" len="med"/>
+                    </a:lnB>
+                    <a:solidFill>
+                      <a:srgbClr val="FFFFFF"/>
+                    </a:solidFill>
+                  </a:tcPr>
+                </a:tc>
+                <a:tc>
+                  <a:txBody>
+                    <a:bodyPr/>
+                    <a:lstStyle/>
+                    <a:p>
+                      <a:pPr indent="0" marL="0">
+                        <a:buNone/>
+                      </a:pPr>
+                      <a:r>
+                        <a:rPr lang="en-US" sz="900" dirty="0">
+                          <a:solidFill>
+                            <a:srgbClr val="1F2233"/>
+                          </a:solidFill>
+                          <a:latin typeface="Calibri" pitchFamily="34" charset="0"/>
+                          <a:ea typeface="Calibri" pitchFamily="34" charset="-122"/>
+                          <a:cs typeface="Calibri" pitchFamily="34" charset="-120"/>
+                        </a:rPr>
                         <a:t>Different refresh timing and definitions; no central checks</a:t>
                       </a:r>
-                      <a:endParaRPr lang="en-US" sz="950" dirty="0">
+                      <a:endParaRPr lang="en-US" sz="900" dirty="0">
                         <a:latin typeface="Calibri" charset="0"/>
                         <a:ea typeface="Calibri" charset="0"/>
                         <a:cs typeface="Calibri" charset="0"/>
@@ -3315,7 +3725,7 @@
                         <a:buNone/>
                       </a:pPr>
                       <a:r>
-                        <a:rPr lang="en-US" sz="950" dirty="0">
+                        <a:rPr lang="en-US" sz="900" dirty="0">
                           <a:solidFill>
                             <a:srgbClr val="1F2233"/>
                           </a:solidFill>
@@ -3325,7 +3735,7 @@
                         </a:rPr>
                         <a:t>Kevin to confirm RA5's source; route feeds through the connector</a:t>
                       </a:r>
-                      <a:endParaRPr lang="en-US" sz="950" dirty="0">
+                      <a:endParaRPr lang="en-US" sz="900" dirty="0">
                         <a:latin typeface="Calibri" charset="0"/>
                         <a:ea typeface="Calibri" charset="0"/>
                         <a:cs typeface="Calibri" charset="0"/>
@@ -3383,7 +3793,7 @@
                         <a:buNone/>
                       </a:pPr>
                       <a:r>
-                        <a:rPr lang="en-US" sz="950" b="1" dirty="0">
+                        <a:rPr lang="en-US" sz="900" b="1" dirty="0">
                           <a:solidFill>
                             <a:srgbClr val="8A4B0F"/>
                           </a:solidFill>
@@ -3393,7 +3803,7 @@
                         </a:rPr>
                         <a:t>Medium</a:t>
                       </a:r>
-                      <a:endParaRPr lang="en-US" sz="950" dirty="0">
+                      <a:endParaRPr lang="en-US" sz="900" dirty="0">
                         <a:latin typeface="Calibri" charset="0"/>
                         <a:ea typeface="Calibri" charset="0"/>
                         <a:cs typeface="Calibri" charset="0"/>
@@ -3453,7 +3863,7 @@
                         <a:buNone/>
                       </a:pPr>
                       <a:r>
-                        <a:rPr lang="en-US" sz="950" b="1" dirty="0">
+                        <a:rPr lang="en-US" sz="900" b="1" dirty="0">
                           <a:solidFill>
                             <a:srgbClr val="A3206E"/>
                           </a:solidFill>
@@ -3463,7 +3873,7 @@
                         </a:rPr>
                         <a:t>6</a:t>
                       </a:r>
-                      <a:endParaRPr lang="en-US" sz="950" dirty="0">
+                      <a:endParaRPr lang="en-US" sz="900" dirty="0">
                         <a:latin typeface="Calibri" charset="0"/>
                         <a:ea typeface="Calibri" charset="0"/>
                         <a:cs typeface="Calibri" charset="0"/>
@@ -3521,7 +3931,7 @@
                         <a:buNone/>
                       </a:pPr>
                       <a:r>
-                        <a:rPr lang="en-US" sz="950" b="1" dirty="0">
+                        <a:rPr lang="en-US" sz="900" b="1" dirty="0">
                           <a:solidFill>
                             <a:srgbClr val="2B2350"/>
                           </a:solidFill>
@@ -3531,7 +3941,7 @@
                         </a:rPr>
                         <a:t>Incomplete or unverified bursary feeds</a:t>
                       </a:r>
-                      <a:endParaRPr lang="en-US" sz="950" dirty="0">
+                      <a:endParaRPr lang="en-US" sz="900" dirty="0">
                         <a:latin typeface="Calibri" charset="0"/>
                         <a:ea typeface="Calibri" charset="0"/>
                         <a:cs typeface="Calibri" charset="0"/>
@@ -3589,7 +3999,7 @@
                         <a:buNone/>
                       </a:pPr>
                       <a:r>
-                        <a:rPr lang="en-US" sz="950" dirty="0">
+                        <a:rPr lang="en-US" sz="900" dirty="0">
                           <a:solidFill>
                             <a:srgbClr val="1F2233"/>
                           </a:solidFill>
@@ -3599,7 +4009,7 @@
                         </a:rPr>
                         <a:t>"Can see only ready to outstanding award, not process evidence"; status marked "Finance need to check"</a:t>
                       </a:r>
-                      <a:endParaRPr lang="en-US" sz="950" dirty="0">
+                      <a:endParaRPr lang="en-US" sz="900" dirty="0">
                         <a:latin typeface="Calibri" charset="0"/>
                         <a:ea typeface="Calibri" charset="0"/>
                         <a:cs typeface="Calibri" charset="0"/>
@@ -3657,7 +4067,7 @@
                         <a:buNone/>
                       </a:pPr>
                       <a:r>
-                        <a:rPr lang="en-US" sz="950" dirty="0">
+                        <a:rPr lang="en-US" sz="900" i="1" dirty="0">
                           <a:solidFill>
                             <a:srgbClr val="1F2233"/>
                           </a:solidFill>
@@ -3665,9 +4075,77 @@
                           <a:ea typeface="Calibri" pitchFamily="34" charset="-122"/>
                           <a:cs typeface="Calibri" pitchFamily="34" charset="-120"/>
                         </a:rPr>
+                        <a:t>Evidence checks happen outside the Bursary system, and Finance confirms status separately</a:t>
+                      </a:r>
+                      <a:endParaRPr lang="en-US" sz="900" dirty="0">
+                        <a:latin typeface="Calibri" charset="0"/>
+                        <a:ea typeface="Calibri" charset="0"/>
+                        <a:cs typeface="Calibri" charset="0"/>
+                      </a:endParaRPr>
+                    </a:p>
+                  </a:txBody>
+                  <a:tcPr marL="54864" marR="54864" marT="27432" marB="27432" anchor="ctr">
+                    <a:lnL w="6350" cap="flat" cmpd="sng" algn="ctr">
+                      <a:solidFill>
+                        <a:srgbClr val="D9D4E3"/>
+                      </a:solidFill>
+                      <a:prstDash val="solid"/>
+                      <a:round/>
+                      <a:headEnd type="none" w="med" len="med"/>
+                      <a:tailEnd type="none" w="med" len="med"/>
+                    </a:lnL>
+                    <a:lnR w="6350" cap="flat" cmpd="sng" algn="ctr">
+                      <a:solidFill>
+                        <a:srgbClr val="D9D4E3"/>
+                      </a:solidFill>
+                      <a:prstDash val="solid"/>
+                      <a:round/>
+                      <a:headEnd type="none" w="med" len="med"/>
+                      <a:tailEnd type="none" w="med" len="med"/>
+                    </a:lnR>
+                    <a:lnT w="6350" cap="flat" cmpd="sng" algn="ctr">
+                      <a:solidFill>
+                        <a:srgbClr val="D9D4E3"/>
+                      </a:solidFill>
+                      <a:prstDash val="solid"/>
+                      <a:round/>
+                      <a:headEnd type="none" w="med" len="med"/>
+                      <a:tailEnd type="none" w="med" len="med"/>
+                    </a:lnT>
+                    <a:lnB w="6350" cap="flat" cmpd="sng" algn="ctr">
+                      <a:solidFill>
+                        <a:srgbClr val="D9D4E3"/>
+                      </a:solidFill>
+                      <a:prstDash val="solid"/>
+                      <a:round/>
+                      <a:headEnd type="none" w="med" len="med"/>
+                      <a:tailEnd type="none" w="med" len="med"/>
+                    </a:lnB>
+                    <a:solidFill>
+                      <a:srgbClr val="F7F5FA"/>
+                    </a:solidFill>
+                  </a:tcPr>
+                </a:tc>
+                <a:tc>
+                  <a:txBody>
+                    <a:bodyPr/>
+                    <a:lstStyle/>
+                    <a:p>
+                      <a:pPr indent="0" marL="0">
+                        <a:buNone/>
+                      </a:pPr>
+                      <a:r>
+                        <a:rPr lang="en-US" sz="900" dirty="0">
+                          <a:solidFill>
+                            <a:srgbClr val="1F2233"/>
+                          </a:solidFill>
+                          <a:latin typeface="Calibri" pitchFamily="34" charset="0"/>
+                          <a:ea typeface="Calibri" pitchFamily="34" charset="-122"/>
+                          <a:cs typeface="Calibri" pitchFamily="34" charset="-120"/>
+                        </a:rPr>
                         <a:t>Bursary pipeline in Power BI is only partly visible</a:t>
                       </a:r>
-                      <a:endParaRPr lang="en-US" sz="950" dirty="0">
+                      <a:endParaRPr lang="en-US" sz="900" dirty="0">
                         <a:latin typeface="Calibri" charset="0"/>
                         <a:ea typeface="Calibri" charset="0"/>
                         <a:cs typeface="Calibri" charset="0"/>
@@ -3725,7 +4203,7 @@
                         <a:buNone/>
                       </a:pPr>
                       <a:r>
-                        <a:rPr lang="en-US" sz="950" dirty="0">
+                        <a:rPr lang="en-US" sz="900" dirty="0">
                           <a:solidFill>
                             <a:srgbClr val="1F2233"/>
                           </a:solidFill>
@@ -3735,7 +4213,7 @@
                         </a:rPr>
                         <a:t>Confirm with Finance which Bursary data is complete</a:t>
                       </a:r>
-                      <a:endParaRPr lang="en-US" sz="950" dirty="0">
+                      <a:endParaRPr lang="en-US" sz="900" dirty="0">
                         <a:latin typeface="Calibri" charset="0"/>
                         <a:ea typeface="Calibri" charset="0"/>
                         <a:cs typeface="Calibri" charset="0"/>
@@ -3793,7 +4271,7 @@
                         <a:buNone/>
                       </a:pPr>
                       <a:r>
-                        <a:rPr lang="en-US" sz="950" b="1" dirty="0">
+                        <a:rPr lang="en-US" sz="900" b="1" dirty="0">
                           <a:solidFill>
                             <a:srgbClr val="8A4B0F"/>
                           </a:solidFill>
@@ -3803,7 +4281,7 @@
                         </a:rPr>
                         <a:t>Medium</a:t>
                       </a:r>
-                      <a:endParaRPr lang="en-US" sz="950" dirty="0">
+                      <a:endParaRPr lang="en-US" sz="900" dirty="0">
                         <a:latin typeface="Calibri" charset="0"/>
                         <a:ea typeface="Calibri" charset="0"/>
                         <a:cs typeface="Calibri" charset="0"/>
@@ -3863,7 +4341,7 @@
                         <a:buNone/>
                       </a:pPr>
                       <a:r>
-                        <a:rPr lang="en-US" sz="950" b="1" dirty="0">
+                        <a:rPr lang="en-US" sz="900" b="1" dirty="0">
                           <a:solidFill>
                             <a:srgbClr val="A3206E"/>
                           </a:solidFill>
@@ -3873,7 +4351,7 @@
                         </a:rPr>
                         <a:t>7</a:t>
                       </a:r>
-                      <a:endParaRPr lang="en-US" sz="950" dirty="0">
+                      <a:endParaRPr lang="en-US" sz="900" dirty="0">
                         <a:latin typeface="Calibri" charset="0"/>
                         <a:ea typeface="Calibri" charset="0"/>
                         <a:cs typeface="Calibri" charset="0"/>
@@ -3931,7 +4409,7 @@
                         <a:buNone/>
                       </a:pPr>
                       <a:r>
-                        <a:rPr lang="en-US" sz="950" b="1" dirty="0">
+                        <a:rPr lang="en-US" sz="900" b="1" dirty="0">
                           <a:solidFill>
                             <a:srgbClr val="2B2350"/>
                           </a:solidFill>
@@ -3941,7 +4419,7 @@
                         </a:rPr>
                         <a:t>No status history</a:t>
                       </a:r>
-                      <a:endParaRPr lang="en-US" sz="950" dirty="0">
+                      <a:endParaRPr lang="en-US" sz="900" dirty="0">
                         <a:latin typeface="Calibri" charset="0"/>
                         <a:ea typeface="Calibri" charset="0"/>
                         <a:cs typeface="Calibri" charset="0"/>
@@ -3999,7 +4477,7 @@
                         <a:buNone/>
                       </a:pPr>
                       <a:r>
-                        <a:rPr lang="en-US" sz="950" dirty="0">
+                        <a:rPr lang="en-US" sz="900" dirty="0">
                           <a:solidFill>
                             <a:srgbClr val="1F2233"/>
                           </a:solidFill>
@@ -4009,7 +4487,7 @@
                         </a:rPr>
                         <a:t>Enquirer keeps only each application's current status</a:t>
                       </a:r>
-                      <a:endParaRPr lang="en-US" sz="950" dirty="0">
+                      <a:endParaRPr lang="en-US" sz="900" dirty="0">
                         <a:latin typeface="Calibri" charset="0"/>
                         <a:ea typeface="Calibri" charset="0"/>
                         <a:cs typeface="Calibri" charset="0"/>
@@ -4067,7 +4545,7 @@
                         <a:buNone/>
                       </a:pPr>
                       <a:r>
-                        <a:rPr lang="en-US" sz="950" dirty="0">
+                        <a:rPr lang="en-US" sz="900" i="1" dirty="0">
                           <a:solidFill>
                             <a:srgbClr val="1F2233"/>
                           </a:solidFill>
@@ -4075,9 +4553,77 @@
                           <a:ea typeface="Calibri" pitchFamily="34" charset="-122"/>
                           <a:cs typeface="Calibri" pitchFamily="34" charset="-120"/>
                         </a:rPr>
+                        <a:t>Each status change overwrites the last one; no snapshot or audit table was set up</a:t>
+                      </a:r>
+                      <a:endParaRPr lang="en-US" sz="900" dirty="0">
+                        <a:latin typeface="Calibri" charset="0"/>
+                        <a:ea typeface="Calibri" charset="0"/>
+                        <a:cs typeface="Calibri" charset="0"/>
+                      </a:endParaRPr>
+                    </a:p>
+                  </a:txBody>
+                  <a:tcPr marL="54864" marR="54864" marT="27432" marB="27432" anchor="ctr">
+                    <a:lnL w="6350" cap="flat" cmpd="sng" algn="ctr">
+                      <a:solidFill>
+                        <a:srgbClr val="D9D4E3"/>
+                      </a:solidFill>
+                      <a:prstDash val="solid"/>
+                      <a:round/>
+                      <a:headEnd type="none" w="med" len="med"/>
+                      <a:tailEnd type="none" w="med" len="med"/>
+                    </a:lnL>
+                    <a:lnR w="6350" cap="flat" cmpd="sng" algn="ctr">
+                      <a:solidFill>
+                        <a:srgbClr val="D9D4E3"/>
+                      </a:solidFill>
+                      <a:prstDash val="solid"/>
+                      <a:round/>
+                      <a:headEnd type="none" w="med" len="med"/>
+                      <a:tailEnd type="none" w="med" len="med"/>
+                    </a:lnR>
+                    <a:lnT w="6350" cap="flat" cmpd="sng" algn="ctr">
+                      <a:solidFill>
+                        <a:srgbClr val="D9D4E3"/>
+                      </a:solidFill>
+                      <a:prstDash val="solid"/>
+                      <a:round/>
+                      <a:headEnd type="none" w="med" len="med"/>
+                      <a:tailEnd type="none" w="med" len="med"/>
+                    </a:lnT>
+                    <a:lnB w="6350" cap="flat" cmpd="sng" algn="ctr">
+                      <a:solidFill>
+                        <a:srgbClr val="D9D4E3"/>
+                      </a:solidFill>
+                      <a:prstDash val="solid"/>
+                      <a:round/>
+                      <a:headEnd type="none" w="med" len="med"/>
+                      <a:tailEnd type="none" w="med" len="med"/>
+                    </a:lnB>
+                    <a:solidFill>
+                      <a:srgbClr val="FFFFFF"/>
+                    </a:solidFill>
+                  </a:tcPr>
+                </a:tc>
+                <a:tc>
+                  <a:txBody>
+                    <a:bodyPr/>
+                    <a:lstStyle/>
+                    <a:p>
+                      <a:pPr indent="0" marL="0">
+                        <a:buNone/>
+                      </a:pPr>
+                      <a:r>
+                        <a:rPr lang="en-US" sz="900" dirty="0">
+                          <a:solidFill>
+                            <a:srgbClr val="1F2233"/>
+                          </a:solidFill>
+                          <a:latin typeface="Calibri" pitchFamily="34" charset="0"/>
+                          <a:ea typeface="Calibri" pitchFamily="34" charset="-122"/>
+                          <a:cs typeface="Calibri" pitchFamily="34" charset="-120"/>
+                        </a:rPr>
                         <a:t>Past offer counts cannot be rebuilt; 3-year trends understate offers</a:t>
                       </a:r>
-                      <a:endParaRPr lang="en-US" sz="950" dirty="0">
+                      <a:endParaRPr lang="en-US" sz="900" dirty="0">
                         <a:latin typeface="Calibri" charset="0"/>
                         <a:ea typeface="Calibri" charset="0"/>
                         <a:cs typeface="Calibri" charset="0"/>
@@ -4135,7 +4681,7 @@
                         <a:buNone/>
                       </a:pPr>
                       <a:r>
-                        <a:rPr lang="en-US" sz="950" dirty="0">
+                        <a:rPr lang="en-US" sz="900" dirty="0">
                           <a:solidFill>
                             <a:srgbClr val="1F2233"/>
                           </a:solidFill>
@@ -4145,7 +4691,7 @@
                         </a:rPr>
                         <a:t>Start weekly status snapshots now (Lesley)</a:t>
                       </a:r>
-                      <a:endParaRPr lang="en-US" sz="950" dirty="0">
+                      <a:endParaRPr lang="en-US" sz="900" dirty="0">
                         <a:latin typeface="Calibri" charset="0"/>
                         <a:ea typeface="Calibri" charset="0"/>
                         <a:cs typeface="Calibri" charset="0"/>
@@ -4203,7 +4749,7 @@
                         <a:buNone/>
                       </a:pPr>
                       <a:r>
-                        <a:rPr lang="en-US" sz="950" b="1" dirty="0">
+                        <a:rPr lang="en-US" sz="900" b="1" dirty="0">
                           <a:solidFill>
                             <a:srgbClr val="8A4B0F"/>
                           </a:solidFill>
@@ -4213,7 +4759,7 @@
                         </a:rPr>
                         <a:t>Medium</a:t>
                       </a:r>
-                      <a:endParaRPr lang="en-US" sz="950" dirty="0">
+                      <a:endParaRPr lang="en-US" sz="900" dirty="0">
                         <a:latin typeface="Calibri" charset="0"/>
                         <a:ea typeface="Calibri" charset="0"/>
                         <a:cs typeface="Calibri" charset="0"/>
@@ -4273,7 +4819,7 @@
                         <a:buNone/>
                       </a:pPr>
                       <a:r>
-                        <a:rPr lang="en-US" sz="950" b="1" dirty="0">
+                        <a:rPr lang="en-US" sz="900" b="1" dirty="0">
                           <a:solidFill>
                             <a:srgbClr val="A3206E"/>
                           </a:solidFill>
@@ -4283,7 +4829,7 @@
                         </a:rPr>
                         <a:t>8</a:t>
                       </a:r>
-                      <a:endParaRPr lang="en-US" sz="950" dirty="0">
+                      <a:endParaRPr lang="en-US" sz="900" dirty="0">
                         <a:latin typeface="Calibri" charset="0"/>
                         <a:ea typeface="Calibri" charset="0"/>
                         <a:cs typeface="Calibri" charset="0"/>
@@ -4341,7 +4887,7 @@
                         <a:buNone/>
                       </a:pPr>
                       <a:r>
-                        <a:rPr lang="en-US" sz="950" b="1" dirty="0">
+                        <a:rPr lang="en-US" sz="900" b="1" dirty="0">
                           <a:solidFill>
                             <a:srgbClr val="2B2350"/>
                           </a:solidFill>
@@ -4351,7 +4897,7 @@
                         </a:rPr>
                         <a:t>Student systems outside the mapped flows</a:t>
                       </a:r>
-                      <a:endParaRPr lang="en-US" sz="950" dirty="0">
+                      <a:endParaRPr lang="en-US" sz="900" dirty="0">
                         <a:latin typeface="Calibri" charset="0"/>
                         <a:ea typeface="Calibri" charset="0"/>
                         <a:cs typeface="Calibri" charset="0"/>
@@ -4409,7 +4955,7 @@
                         <a:buNone/>
                       </a:pPr>
                       <a:r>
-                        <a:rPr lang="en-US" sz="950" dirty="0">
+                        <a:rPr lang="en-US" sz="900" dirty="0">
                           <a:solidFill>
                             <a:srgbClr val="1F2233"/>
                           </a:solidFill>
@@ -4417,9 +4963,9 @@
                           <a:ea typeface="Calibri" pitchFamily="34" charset="-122"/>
                           <a:cs typeface="Calibri" pitchFamily="34" charset="-120"/>
                         </a:rPr>
-                        <a:t>7 systems in the "Don't know" group, including Theorise and CaseNotes; open "Check with" notes; bank details sent to Finance by hand</a:t>
-                      </a:r>
-                      <a:endParaRPr lang="en-US" sz="950" dirty="0">
+                        <a:t>7 systems in the "Don't know" group, incl. Theorise and CaseNotes; open "Check with" notes; bank details sent to Finance by hand</a:t>
+                      </a:r>
+                      <a:endParaRPr lang="en-US" sz="900" dirty="0">
                         <a:latin typeface="Calibri" charset="0"/>
                         <a:ea typeface="Calibri" charset="0"/>
                         <a:cs typeface="Calibri" charset="0"/>
@@ -4477,7 +5023,7 @@
                         <a:buNone/>
                       </a:pPr>
                       <a:r>
-                        <a:rPr lang="en-US" sz="950" dirty="0">
+                        <a:rPr lang="en-US" sz="900" i="1" dirty="0">
                           <a:solidFill>
                             <a:srgbClr val="1F2233"/>
                           </a:solidFill>
@@ -4485,9 +5031,77 @@
                           <a:ea typeface="Calibri" pitchFamily="34" charset="-122"/>
                           <a:cs typeface="Calibri" pitchFamily="34" charset="-120"/>
                         </a:rPr>
+                        <a:t>Systems bought by individual teams without a central register; some owners have left</a:t>
+                      </a:r>
+                      <a:endParaRPr lang="en-US" sz="900" dirty="0">
+                        <a:latin typeface="Calibri" charset="0"/>
+                        <a:ea typeface="Calibri" charset="0"/>
+                        <a:cs typeface="Calibri" charset="0"/>
+                      </a:endParaRPr>
+                    </a:p>
+                  </a:txBody>
+                  <a:tcPr marL="54864" marR="54864" marT="27432" marB="27432" anchor="ctr">
+                    <a:lnL w="6350" cap="flat" cmpd="sng" algn="ctr">
+                      <a:solidFill>
+                        <a:srgbClr val="D9D4E3"/>
+                      </a:solidFill>
+                      <a:prstDash val="solid"/>
+                      <a:round/>
+                      <a:headEnd type="none" w="med" len="med"/>
+                      <a:tailEnd type="none" w="med" len="med"/>
+                    </a:lnL>
+                    <a:lnR w="6350" cap="flat" cmpd="sng" algn="ctr">
+                      <a:solidFill>
+                        <a:srgbClr val="D9D4E3"/>
+                      </a:solidFill>
+                      <a:prstDash val="solid"/>
+                      <a:round/>
+                      <a:headEnd type="none" w="med" len="med"/>
+                      <a:tailEnd type="none" w="med" len="med"/>
+                    </a:lnR>
+                    <a:lnT w="6350" cap="flat" cmpd="sng" algn="ctr">
+                      <a:solidFill>
+                        <a:srgbClr val="D9D4E3"/>
+                      </a:solidFill>
+                      <a:prstDash val="solid"/>
+                      <a:round/>
+                      <a:headEnd type="none" w="med" len="med"/>
+                      <a:tailEnd type="none" w="med" len="med"/>
+                    </a:lnT>
+                    <a:lnB w="6350" cap="flat" cmpd="sng" algn="ctr">
+                      <a:solidFill>
+                        <a:srgbClr val="D9D4E3"/>
+                      </a:solidFill>
+                      <a:prstDash val="solid"/>
+                      <a:round/>
+                      <a:headEnd type="none" w="med" len="med"/>
+                      <a:tailEnd type="none" w="med" len="med"/>
+                    </a:lnB>
+                    <a:solidFill>
+                      <a:srgbClr val="F7F5FA"/>
+                    </a:solidFill>
+                  </a:tcPr>
+                </a:tc>
+                <a:tc>
+                  <a:txBody>
+                    <a:bodyPr/>
+                    <a:lstStyle/>
+                    <a:p>
+                      <a:pPr indent="0" marL="0">
+                        <a:buNone/>
+                      </a:pPr>
+                      <a:r>
+                        <a:rPr lang="en-US" sz="900" dirty="0">
+                          <a:solidFill>
+                            <a:srgbClr val="1F2233"/>
+                          </a:solidFill>
+                          <a:latin typeface="Calibri" pitchFamily="34" charset="0"/>
+                          <a:ea typeface="Calibri" pitchFamily="34" charset="-122"/>
+                          <a:cs typeface="Calibri" pitchFamily="34" charset="-120"/>
+                        </a:rPr>
                         <a:t>ASN picture may be incomplete; sensitive data sits outside the managed flow</a:t>
                       </a:r>
-                      <a:endParaRPr lang="en-US" sz="950" dirty="0">
+                      <a:endParaRPr lang="en-US" sz="900" dirty="0">
                         <a:latin typeface="Calibri" charset="0"/>
                         <a:ea typeface="Calibri" charset="0"/>
                         <a:cs typeface="Calibri" charset="0"/>
@@ -4545,7 +5159,7 @@
                         <a:buNone/>
                       </a:pPr>
                       <a:r>
-                        <a:rPr lang="en-US" sz="950" dirty="0">
+                        <a:rPr lang="en-US" sz="900" dirty="0">
                           <a:solidFill>
                             <a:srgbClr val="1F2233"/>
                           </a:solidFill>
@@ -4555,7 +5169,7 @@
                         </a:rPr>
                         <a:t>Close open notes, Theorise and CaseNotes first</a:t>
                       </a:r>
-                      <a:endParaRPr lang="en-US" sz="950" dirty="0">
+                      <a:endParaRPr lang="en-US" sz="900" dirty="0">
                         <a:latin typeface="Calibri" charset="0"/>
                         <a:ea typeface="Calibri" charset="0"/>
                         <a:cs typeface="Calibri" charset="0"/>
@@ -4613,7 +5227,7 @@
                         <a:buNone/>
                       </a:pPr>
                       <a:r>
-                        <a:rPr lang="en-US" sz="950" b="1" dirty="0">
+                        <a:rPr lang="en-US" sz="900" b="1" dirty="0">
                           <a:solidFill>
                             <a:srgbClr val="8A4B0F"/>
                           </a:solidFill>
@@ -4623,7 +5237,7 @@
                         </a:rPr>
                         <a:t>Medium</a:t>
                       </a:r>
-                      <a:endParaRPr lang="en-US" sz="950" dirty="0">
+                      <a:endParaRPr lang="en-US" sz="900" dirty="0">
                         <a:latin typeface="Calibri" charset="0"/>
                         <a:ea typeface="Calibri" charset="0"/>
                         <a:cs typeface="Calibri" charset="0"/>
@@ -4707,7 +5321,7 @@
                   <a:srgbClr val="6B6F80"/>
                 </a:solidFill>
               </a:rPr>
-              <a:t>Source: System Architecture working file (Lucid), checked 6 Oct 2026. Line labels were matched to lines by position on the page; confirm any that look wrong.</a:t>
+              <a:t>Source: System Architecture working file (Lucid), checked 6 Oct 2026. Causes are likely explanations to confirm with system owners. Line labels were matched to lines by position on the page.</a:t>
             </a:r>
             <a:endParaRPr lang="en-US" sz="900" dirty="0"/>
           </a:p>

</xml_diff>